<commit_message>
fix(buildathon): generate EN .pptx deck + fix EN page link
- Made build_deck.py bilingual: accepts "fr" or "en" arg, reads the corresponding HTML, outputs separate file
- Generated buildathon-deck-en.pptx from /en/buildathon.html (English section titles + EN cover slide)
- Cover slide copy is now language-aware (eyebrow stays bilingual, subtitle/summary/footer adapt)
- Section "RECOMMANDATION" pill becomes "RECOMMENDATION" on EN slides
- Footer URL: /buildathon (FR) vs /en/buildathon (EN)
- Updated /en/buildathon.html link: /buildathon-deck.pptx → /buildathon-deck-en.pptx
- FR deck regenerated for parity (no content change)
</commit_message>
<xml_diff>
--- a/buildathon-deck.pptx
+++ b/buildathon-deck.pptx
@@ -7250,7 +7250,7 @@
                 </a:solidFill>
                 <a:latin typeface="Helvetica Neue"/>
               </a:rPr>
-              <a:t>Les équipes choisissent un challenge parmi les 39 opportunités APP du registre, réparties sur 7 thèmes : Wallets (6) · Infra (4) · Lending (5) · RWA &amp; Stables (5) · EVM DeFi (6) · Dev Tooling (4) · AI Agents (9). Bracket des prix mappé sur les 3 tiers du registre :</a:t>
+              <a:t>Les OPP du registre sont des opportunités identifiées — des idées sur lesquelles nous pensons qu'il existe un potentiel besoin (signaux convergents PWG + ATKA + écosystème + YC + interviews founders). Elles ne sont en aucun cas un cadre restrictif. Tous les projets XRPL sont permis et bienvenus — qu'ils correspondent à une OPP, qu'ils en combinent plusieurs, ou qu'ils proposent quelque chose de complètement différent. Le registre est un point de départ pour aider les builders qui cherchent l'inspiration, pas une checklist obligatoire.</a:t>
             </a:r>
           </a:p>
         </p:txBody>
@@ -7263,7 +7263,7 @@
         </p:nvSpPr>
         <p:spPr>
           <a:xfrm>
-            <a:off x="502920" y="4145280"/>
+            <a:off x="502920" y="4343400"/>
             <a:ext cx="11185855" cy="2286000"/>
           </a:xfrm>
           <a:prstGeom prst="rect">

</xml_diff>